<commit_message>
pptx: no stroke="0" on the wave paths, so a deck imports into Google Slides
Google Slides' pptx import refused every framework deck ("Upload failed"): a filled custom path
marked stroke="0" (the wave bands and the cover field) is enough to fail the file, though
PowerPoint takes it. Bisected on the storage report with Ben's uploads: pandoc's own template
imports; ours fails; without the drawn shapes, or with the lines alone, it imports; with the bands
alone it fails; with the bands but no stroke attribute it imports.

The outline was already off through each shape's <a:ln><a:noFill/>, so pptx_waves.geom() drops the
attribute and nothing looks different. The four templates with waves (ncar, ncarucar, ucar, ucp)
are regenerated; the only change in them is that attribute. livery check fails a template whose
custom path carries it.

Co-Authored-By: Claude Opus 5.5 <noreply@anthropic.com>
Claude-Session: https://claude.ai/code/session_018sZZ6Tdo7VuWcb619dTZBP
</commit_message>
<xml_diff>
--- a/liveries/ncar/template.pptx
+++ b/liveries/ncar/template.pptx
@@ -58,7 +58,7 @@
             <a:cxnLst/>
             <a:rect l="0" t="0" r="r" b="b"/>
             <a:pathLst>
-              <a:path w="16000" h="9000" stroke="0">
+              <a:path w="16000" h="9000">
                 <a:moveTo>
                   <a:pt x="10979" y="0"/>
                 </a:moveTo>
@@ -117,7 +117,7 @@
             <a:cxnLst/>
             <a:rect l="0" t="0" r="r" b="b"/>
             <a:pathLst>
-              <a:path w="16000" h="9000" stroke="0">
+              <a:path w="16000" h="9000">
                 <a:moveTo>
                   <a:pt x="11421" y="0"/>
                 </a:moveTo>
@@ -1222,7 +1222,7 @@
             <a:cxnLst/>
             <a:rect l="0" t="0" r="r" b="b"/>
             <a:pathLst>
-              <a:path w="16000" h="9000" stroke="0">
+              <a:path w="16000" h="9000">
                 <a:moveTo>
                   <a:pt x="11939" y="0"/>
                 </a:moveTo>
@@ -1281,7 +1281,7 @@
             <a:cxnLst/>
             <a:rect l="0" t="0" r="r" b="b"/>
             <a:pathLst>
-              <a:path w="16000" h="9000" stroke="0">
+              <a:path w="16000" h="9000">
                 <a:moveTo>
                   <a:pt x="12381" y="0"/>
                 </a:moveTo>
@@ -2627,7 +2627,7 @@
             <a:cxnLst/>
             <a:rect l="0" t="0" r="r" b="b"/>
             <a:pathLst>
-              <a:path w="16000" h="9000" stroke="0">
+              <a:path w="16000" h="9000">
                 <a:moveTo>
                   <a:pt x="10979" y="0"/>
                 </a:moveTo>
@@ -2686,7 +2686,7 @@
             <a:cxnLst/>
             <a:rect l="0" t="0" r="r" b="b"/>
             <a:pathLst>
-              <a:path w="16000" h="9000" stroke="0">
+              <a:path w="16000" h="9000">
                 <a:moveTo>
                   <a:pt x="11421" y="0"/>
                 </a:moveTo>

</xml_diff>